<commit_message>
Level 5 Lesson 8 draft listening audio (1:43)
</commit_message>
<xml_diff>
--- a/level5/slides/Level5_Lesson8_Slides.pptx
+++ b/level5/slides/Level5_Lesson8_Slides.pptx
@@ -8,32 +8,32 @@
     <p:notesMasterId r:id="rId22"/>
   </p:notesMasterIdLst>
   <p:sldIdLst>
-    <p:sldId id="939" r:id="rId33"/>
-    <p:sldId id="940" r:id="rId34"/>
-    <p:sldId id="941" r:id="rId35"/>
-    <p:sldId id="942" r:id="rId36"/>
-    <p:sldId id="943" r:id="rId31"/>
-    <p:sldId id="944" r:id="rId30"/>
-    <p:sldId id="945" r:id="rId29"/>
-    <p:sldId id="946" r:id="rId28"/>
-    <p:sldId id="947" r:id="rId27"/>
-    <p:sldId id="948" r:id="rId20"/>
-    <p:sldId id="949" r:id="rId18"/>
-    <p:sldId id="950" r:id="rId17"/>
-    <p:sldId id="951" r:id="rId16"/>
-    <p:sldId id="952" r:id="rId14"/>
-    <p:sldId id="953" r:id="rId13"/>
-    <p:sldId id="954" r:id="rId12"/>
-    <p:sldId id="955" r:id="rId11"/>
-    <p:sldId id="956" r:id="rId10"/>
-    <p:sldId id="957" r:id="rId8"/>
-    <p:sldId id="958" r:id="rId7"/>
-    <p:sldId id="959" r:id="rId6"/>
-    <p:sldId id="960" r:id="rId5"/>
-    <p:sldId id="961" r:id="rId4"/>
-    <p:sldId id="962" r:id="rId3"/>
-    <p:sldId id="963" r:id="rId57"/>
-    <p:sldId id="964" r:id="rId2"/>
+    <p:sldId id="991" r:id="rId33"/>
+    <p:sldId id="992" r:id="rId34"/>
+    <p:sldId id="993" r:id="rId35"/>
+    <p:sldId id="994" r:id="rId36"/>
+    <p:sldId id="995" r:id="rId31"/>
+    <p:sldId id="996" r:id="rId30"/>
+    <p:sldId id="997" r:id="rId29"/>
+    <p:sldId id="998" r:id="rId28"/>
+    <p:sldId id="999" r:id="rId27"/>
+    <p:sldId id="1000" r:id="rId20"/>
+    <p:sldId id="1001" r:id="rId18"/>
+    <p:sldId id="1002" r:id="rId17"/>
+    <p:sldId id="1003" r:id="rId16"/>
+    <p:sldId id="1004" r:id="rId14"/>
+    <p:sldId id="1005" r:id="rId13"/>
+    <p:sldId id="1006" r:id="rId12"/>
+    <p:sldId id="1007" r:id="rId11"/>
+    <p:sldId id="1008" r:id="rId10"/>
+    <p:sldId id="1009" r:id="rId8"/>
+    <p:sldId id="1010" r:id="rId7"/>
+    <p:sldId id="1011" r:id="rId6"/>
+    <p:sldId id="1012" r:id="rId5"/>
+    <p:sldId id="1013" r:id="rId4"/>
+    <p:sldId id="1014" r:id="rId3"/>
+    <p:sldId id="1015" r:id="rId57"/>
+    <p:sldId id="1016" r:id="rId2"/>
   </p:sldIdLst>
   <p:sldSz cx="12192000" cy="6858000"/>
   <p:notesSz cx="6858000" cy="12192000"/>
@@ -536,7 +536,7 @@
           </a:p>
           <a:p>
             <a:r>
-              <a:t>Audio: the listening audio for this lesson (about 2:20) is coming soon. It will use computer-generated voices (Chatterbox TTS cloned from synthetic Kokoro-82M reference clips); no recordings of real people. Until it is ready, read the listening script (in the notes of the Before You Listen slide) with a volunteer. The names and the story are invented.</a:t>
+              <a:t>Audio: synthetic voices, computer-generated (Chatterbox TTS cloned from Kokoro-82M reference clips). No recordings of real people. The names and the story are invented.</a:t>
             </a:r>
           </a:p>
           <a:p>
@@ -1417,126 +1417,6 @@
           <a:p>
             <a:r>
               <a:t>Picture: Twemoji graphics by Twitter, Inc. and other contributors (https://github.com/jdecked/twemoji), CC BY 4.0 (https://creativecommons.org/licenses/by/4.0/); resized and combined, with signs and labels (images/CREDITS.md).</a:t>
-            </a:r>
-          </a:p>
-          <a:p>
-            <a:r>
-              <a:t>Listening script (the audio is coming soon; until then, read it aloud with a volunteer at a normal, friendly speed):</a:t>
-            </a:r>
-          </a:p>
-          <a:p>
-            <a:r>
-              <a:t>Narrator: Lesson eight. Maya is calling the office at Northside School. She volunteers for the after-school reading hour. Mr. Reed answers the phone.</a:t>
-            </a:r>
-          </a:p>
-          <a:p>
-            <a:r>
-              <a:t>Mr. Reed: Northside School office. This is Mr. Reed.</a:t>
-            </a:r>
-          </a:p>
-          <a:p>
-            <a:r>
-              <a:t>Maya: Hello. This is Maya. I want to ask about the conference.</a:t>
-            </a:r>
-          </a:p>
-          <a:p>
-            <a:r>
-              <a:t>Mr. Reed: Of course. How can I help you?</a:t>
-            </a:r>
-          </a:p>
-          <a:p>
-            <a:r>
-              <a:t>Maya: Do you know if the conference is tonight?</a:t>
-            </a:r>
-          </a:p>
-          <a:p>
-            <a:r>
-              <a:t>Mr. Reed: Yes. It starts at six thirty, in the library.</a:t>
-            </a:r>
-          </a:p>
-          <a:p>
-            <a:r>
-              <a:t>Maya: Thank you. Do you know whether I should bring the signup sheet?</a:t>
-            </a:r>
-          </a:p>
-          <a:p>
-            <a:r>
-              <a:t>Mr. Reed: Yes. Please bring the signup sheet. I'm going to set it by the office window.</a:t>
-            </a:r>
-          </a:p>
-          <a:p>
-            <a:r>
-              <a:t>Maya: Do you know where the office window is?</a:t>
-            </a:r>
-          </a:p>
-          <a:p>
-            <a:r>
-              <a:t>Mr. Reed: It's down the hallway, past the bell.</a:t>
-            </a:r>
-          </a:p>
-          <a:p>
-            <a:r>
-              <a:t>Maya: Can you tell me if I need a permission slip? I'm a volunteer, not a parent.</a:t>
-            </a:r>
-          </a:p>
-          <a:p>
-            <a:r>
-              <a:t>Mr. Reed: A volunteer does not need a slip. A parent brings a permission slip for early pickup.</a:t>
-            </a:r>
-          </a:p>
-          <a:p>
-            <a:r>
-              <a:t>Maya: Do you know when I should arrive?</a:t>
-            </a:r>
-          </a:p>
-          <a:p>
-            <a:r>
-              <a:t>Mr. Reed: Please arrive ten minutes early.</a:t>
-            </a:r>
-          </a:p>
-          <a:p>
-            <a:r>
-              <a:t>Maya: I will. I'm going to put the sheet in my backpack.</a:t>
-            </a:r>
-          </a:p>
-          <a:p>
-            <a:r>
-              <a:t>Maya: Do you know where I should leave my backpack?</a:t>
-            </a:r>
-          </a:p>
-          <a:p>
-            <a:r>
-              <a:t>Mr. Reed: Leave it by the office window.</a:t>
-            </a:r>
-          </a:p>
-          <a:p>
-            <a:r>
-              <a:t>Mr. Reed: The newsletter also says the conference is tonight.</a:t>
-            </a:r>
-          </a:p>
-          <a:p>
-            <a:r>
-              <a:t>Maya: Do you know if dismissal is at the usual time?</a:t>
-            </a:r>
-          </a:p>
-          <a:p>
-            <a:r>
-              <a:t>Mr. Reed: Yes. Dismissal is at three. The conference is in the evening.</a:t>
-            </a:r>
-          </a:p>
-          <a:p>
-            <a:r>
-              <a:t>Maya: Thank you. I don't want to miss the start.</a:t>
-            </a:r>
-          </a:p>
-          <a:p>
-            <a:r>
-              <a:t>Mr. Reed: You're welcome. We'll see you ten minutes early.</a:t>
-            </a:r>
-          </a:p>
-          <a:p>
-            <a:r>
-              <a:t>Narrator: That's the end of the listening.</a:t>
             </a:r>
           </a:p>
         </p:txBody>
@@ -11168,7 +11048,7 @@
                 <a:ea typeface="Lexend Deca" pitchFamily="34" charset="-122"/>
                 <a:cs typeface="Lexend Deca" pitchFamily="34" charset="-120"/>
               </a:rPr>
-              <a:t>Audio (about 2:20): coming soon.</a:t>
+              <a:t>Audio: about 1:43. It plays once.</a:t>
             </a:r>
             <a:endParaRPr lang="en-US" sz="2200" dirty="0"/>
           </a:p>
@@ -29775,7 +29655,7 @@
                 <a:ea typeface="Lexend Deca" pitchFamily="34" charset="-122"/>
                 <a:cs typeface="Lexend Deca" pitchFamily="34" charset="-120"/>
               </a:rPr>
-              <a:t>Audio (coming soon): synthetic voices made with Chatterbox TTS (MIT License), cloned from short synthetic reference clips made with Kokoro-82M (Apache License 2.0). No recordings of real people. Each file will carry an inaudible Perth watermark marking it as AI-generated. Font: Lexend Deca (OFL 1.1).</a:t>
+              <a:t>Audio: synthetic voices made with Chatterbox TTS (MIT License), cloned from short synthetic reference clips made with Kokoro-82M (Apache License 2.0). No recordings of real people were used. Each file carries an inaudible Perth watermark marking it as AI-generated. Font: Lexend Deca (OFL 1.1).</a:t>
             </a:r>
             <a:endParaRPr lang="en-US" sz="1350" dirty="0" b="0"/>
           </a:p>

</xml_diff>